<commit_message>
fix: correct all Journey A/B/C numbers in pitch deck from live simulation data
Journey A (was wrong everywhere):
- First purchase: 84.5% (was showing 99%)
- Reorder rate: 60.4% (was wrong 98%)
- Lapse: 39.6% (was wrong 2%)
- Probes: social proof 0%, outcome data 0%, loyalty price 50% (CONFIRMED)
- Re-simulation: 60.4% -> 80.2% (was 98% -> 99%)
- Interventions: loyalty price +19.8pp, expert consult +10.6pp, pharmacist defense
- Hypothesis tree: social proof REJECTED, outcome PARTIAL, trigger CONFIRMED

Cross-journey synthesis: updated all three journey summaries with verified numbers

Co-Authored-By: Claude Sonnet 4.6 <noreply@anthropic.com>
</commit_message>
<xml_diff>
--- a/reports/Simulatte_LittleJoys_PitchDeck.pptx
+++ b/reports/Simulatte_LittleJoys_PitchDeck.pptx
@@ -3972,7 +3972,7 @@
                 <a:ea typeface="Barlow" pitchFamily="34" charset="-122"/>
                 <a:cs typeface="Barlow" pitchFamily="34" charset="-120"/>
               </a:rPr>
-              <a:t>Strong trial rates and positive NPS. Near-universal reorder. But 2% of buyers lapsed at cycle 2 with no discount trigger. What was the precise mechanism — and what stimulus would protect it at scale?</a:t>
+              <a:t>Strong NPS. 84.5% first purchase. But 39.6% of buyers never reorder. No trigger, no nudge — the trial discount expires and the habit window closes. What's the precise signal that locks in cycle 2?</a:t>
             </a:r>
             <a:endParaRPr lang="en-US" sz="900" dirty="0"/>
           </a:p>
@@ -4011,7 +4011,7 @@
                 <a:ea typeface="Barlow Condensed" pitchFamily="34" charset="-122"/>
                 <a:cs typeface="Barlow Condensed" pitchFamily="34" charset="-120"/>
               </a:rPr>
-              <a:t>98.0%</a:t>
+              <a:t>60.4%</a:t>
             </a:r>
             <a:endParaRPr lang="en-US" sz="2200" dirty="0"/>
           </a:p>
@@ -5833,7 +5833,7 @@
                 <a:ea typeface="IBM Plex Mono" pitchFamily="34" charset="-122"/>
                 <a:cs typeface="IBM Plex Mono" pitchFamily="34" charset="-120"/>
               </a:rPr>
-              <a:t>TRIAL RATE</a:t>
+              <a:t>FIRST PURCHASE</a:t>
             </a:r>
             <a:endParaRPr lang="en-US" sz="850" dirty="0"/>
           </a:p>
@@ -5872,7 +5872,7 @@
                 <a:ea typeface="Barlow Condensed" pitchFamily="34" charset="-122"/>
                 <a:cs typeface="Barlow Condensed" pitchFamily="34" charset="-120"/>
               </a:rPr>
-              <a:t>99.0%</a:t>
+              <a:t>84.5%</a:t>
             </a:r>
             <a:endParaRPr lang="en-US" sz="4400" dirty="0"/>
           </a:p>
@@ -5975,7 +5975,7 @@
                 <a:ea typeface="Barlow Condensed" pitchFamily="34" charset="-122"/>
                 <a:cs typeface="Barlow Condensed" pitchFamily="34" charset="-120"/>
               </a:rPr>
-              <a:t>98.0%</a:t>
+              <a:t>60.4%</a:t>
             </a:r>
             <a:endParaRPr lang="en-US" sz="4400" dirty="0"/>
           </a:p>
@@ -6014,7 +6014,7 @@
                 <a:ea typeface="IBM Plex Mono" pitchFamily="34" charset="-122"/>
                 <a:cs typeface="IBM Plex Mono" pitchFamily="34" charset="-120"/>
               </a:rPr>
-              <a:t>2.0% OF BUYERS DID NOT REORDER AT FULL PRICE  ·  61-DAY JOURNEY  ·  AGE 2–6 COHORT</a:t>
+              <a:t>39.6% DID NOT REORDER  ·  200 PERSONAS  ·  61-DAY JOURNEY  ·  AGE 2–6 COHORT</a:t>
             </a:r>
             <a:endParaRPr lang="en-US" sz="850" dirty="0"/>
           </a:p>
@@ -6142,7 +6142,7 @@
                 <a:ea typeface="Barlow" pitchFamily="34" charset="-122"/>
                 <a:cs typeface="Barlow" pitchFamily="34" charset="-120"/>
               </a:rPr>
-              <a:t>98% came back. The 2% who didn't had no reorder trigger at Day 60. The discount that drove trial had vanished. No nudge. No renewal cue. WOM from Priya created a near-unbreakable purchase habit — the lapse is a trigger absence, not satisfaction failure.</a:t>
+              <a:t>39.6% of buyers lapsed. Social proof (0%) and outcome data (0%) had zero effect. Only one signal worked: a loyalty price prompt at Day 55. A-P1 (Rs 599 loyalty price) converted 50% of lapsers. The lapse is a trigger absence — not satisfaction failure, not brand distrust.</a:t>
             </a:r>
             <a:endParaRPr lang="en-US" sz="1050" dirty="0"/>
           </a:p>
@@ -6181,7 +6181,7 @@
                 <a:ea typeface="IBM Plex Mono" pitchFamily="34" charset="-122"/>
                 <a:cs typeface="IBM Plex Mono" pitchFamily="34" charset="-120"/>
               </a:rPr>
-              <a:t>CONFIRMED: No reorder trigger (Day 55–60) · Price sensitivity at full price</a:t>
+              <a:t>A-P1 (loyalty price trigger): 50% convert. A-P2 (social proof): 0%. A-P3 (outcome data): 0%.</a:t>
             </a:r>
             <a:endParaRPr lang="en-US" sz="850" dirty="0"/>
           </a:p>
@@ -6323,7 +6323,7 @@
                 <a:ea typeface="Barlow" pitchFamily="34" charset="-122"/>
                 <a:cs typeface="Barlow" pitchFamily="34" charset="-120"/>
               </a:rPr>
-              <a:t>Habit not formed</a:t>
+              <a:t>Social proof deficit</a:t>
             </a:r>
             <a:endParaRPr lang="en-US" sz="850" dirty="0"/>
           </a:p>
@@ -6356,13 +6356,13 @@
             <a:r>
               <a:rPr lang="en-US" sz="750" b="1" spc="50" kern="0" dirty="0">
                 <a:solidFill>
-                  <a:srgbClr val="A8FF3E"/>
+                  <a:srgbClr val="82817D"/>
                 </a:solidFill>
                 <a:latin typeface="IBM Plex Mono" pitchFamily="34" charset="0"/>
                 <a:ea typeface="IBM Plex Mono" pitchFamily="34" charset="-122"/>
                 <a:cs typeface="IBM Plex Mono" pitchFamily="34" charset="-120"/>
               </a:rPr>
-              <a:t>CONFIRMED</a:t>
+              <a:t>PARTIAL</a:t>
             </a:r>
             <a:endParaRPr lang="en-US" sz="750" dirty="0"/>
           </a:p>
@@ -6401,7 +6401,7 @@
                 <a:ea typeface="Barlow" pitchFamily="34" charset="-122"/>
                 <a:cs typeface="Barlow" pitchFamily="34" charset="-120"/>
               </a:rPr>
-              <a:t>No reorder trigger</a:t>
+              <a:t>Outcome uncertainty</a:t>
             </a:r>
             <a:endParaRPr lang="en-US" sz="850" dirty="0"/>
           </a:p>
@@ -6479,7 +6479,7 @@
                 <a:ea typeface="Barlow" pitchFamily="34" charset="-122"/>
                 <a:cs typeface="Barlow" pitchFamily="34" charset="-120"/>
               </a:rPr>
-              <a:t>Price at full rate</a:t>
+              <a:t>No reorder trigger</a:t>
             </a:r>
             <a:endParaRPr lang="en-US" sz="850" dirty="0"/>
           </a:p>
@@ -6837,7 +6837,7 @@
                 <a:ea typeface="Barlow Condensed" pitchFamily="34" charset="-122"/>
                 <a:cs typeface="Barlow Condensed" pitchFamily="34" charset="-120"/>
               </a:rPr>
-              <a:t>Loyalty Pricing at Reorder</a:t>
+              <a:t>Loyalty Price Trigger at Day 55</a:t>
             </a:r>
             <a:endParaRPr lang="en-US" sz="1150" dirty="0"/>
           </a:p>
@@ -6876,7 +6876,7 @@
                 <a:ea typeface="Barlow" pitchFamily="34" charset="-122"/>
                 <a:cs typeface="Barlow" pitchFamily="34" charset="-120"/>
               </a:rPr>
-              <a:t>₹599 on second pack via app push at Day 55. "Here's your loyalty price."</a:t>
+              <a:t>Rs 599 (vs Rs 649 full price) via app push: 'Here's your loyalty price.' Timed to the exact window lapsers go quiet. A-P1: 50% of lapsers convert.</a:t>
             </a:r>
             <a:endParaRPr lang="en-US" sz="900" dirty="0"/>
           </a:p>
@@ -6915,7 +6915,7 @@
                 <a:ea typeface="IBM Plex Mono" pitchFamily="34" charset="-122"/>
                 <a:cs typeface="IBM Plex Mono" pitchFamily="34" charset="-120"/>
               </a:rPr>
-              <a:t>+10pp reorder rate</a:t>
+              <a:t>+19.8pp reorder rate</a:t>
             </a:r>
             <a:endParaRPr lang="en-US" sz="850" dirty="0"/>
           </a:p>
@@ -7018,7 +7018,7 @@
                 <a:ea typeface="Barlow Condensed" pitchFamily="34" charset="-122"/>
                 <a:cs typeface="Barlow Condensed" pitchFamily="34" charset="-120"/>
               </a:rPr>
-              <a:t>Social Proof Nudge at Day 50</a:t>
+              <a:t>Expert Consultation Offer</a:t>
             </a:r>
             <a:endParaRPr lang="en-US" sz="1150" dirty="0"/>
           </a:p>
@@ -7057,7 +7057,7 @@
                 <a:ea typeface="Barlow" pitchFamily="34" charset="-122"/>
                 <a:cs typeface="Barlow" pitchFamily="34" charset="-120"/>
               </a:rPr>
-              <a:t>WhatsApp: "3,400 parents reordered this month." Peer signal at the decision window.</a:t>
+              <a:t>WhatsApp: 'Chat with a pediatric nutritionist — free for Nutrimix parents.' Addresses outcome uncertainty for the analytical segment. A-P5b: 26.7% convert.</a:t>
             </a:r>
             <a:endParaRPr lang="en-US" sz="900" dirty="0"/>
           </a:p>
@@ -7096,7 +7096,7 @@
                 <a:ea typeface="IBM Plex Mono" pitchFamily="34" charset="-122"/>
                 <a:cs typeface="IBM Plex Mono" pitchFamily="34" charset="-120"/>
               </a:rPr>
-              <a:t>+5pp reorder rate</a:t>
+              <a:t>+10.6pp reorder rate</a:t>
             </a:r>
             <a:endParaRPr lang="en-US" sz="850" dirty="0"/>
           </a:p>
@@ -7199,7 +7199,7 @@
                 <a:ea typeface="Barlow Condensed" pitchFamily="34" charset="-122"/>
                 <a:cs typeface="Barlow Condensed" pitchFamily="34" charset="-120"/>
               </a:rPr>
-              <a:t>LJ Pass Subscription Offer</a:t>
+              <a:t>Pharmacist Competitive Defense</a:t>
             </a:r>
             <a:endParaRPr lang="en-US" sz="1150" dirty="0"/>
           </a:p>
@@ -7238,7 +7238,7 @@
                 <a:ea typeface="Barlow" pitchFamily="34" charset="-122"/>
                 <a:cs typeface="Barlow" pitchFamily="34" charset="-120"/>
               </a:rPr>
-              <a:t>Post-trial: ₹579/month, cancel anytime, delivered before the pack runs out.</a:t>
+              <a:t>Pre-empt Complan displacement: arm pharmacists with Nutrimix iron/B12 comparison at the reorder window. A-P4 shows 20% of lapsers switch on pharmacist push alone.</a:t>
             </a:r>
             <a:endParaRPr lang="en-US" sz="900" dirty="0"/>
           </a:p>
@@ -7277,7 +7277,7 @@
                 <a:ea typeface="IBM Plex Mono" pitchFamily="34" charset="-122"/>
                 <a:cs typeface="IBM Plex Mono" pitchFamily="34" charset="-120"/>
               </a:rPr>
-              <a:t>Churn 29% → 18%</a:t>
+              <a:t>Protect 20% displacement risk</a:t>
             </a:r>
             <a:endParaRPr lang="en-US" sz="850" dirty="0"/>
           </a:p>
@@ -7405,7 +7405,7 @@
                 <a:ea typeface="Barlow Condensed" pitchFamily="34" charset="-122"/>
                 <a:cs typeface="Barlow Condensed" pitchFamily="34" charset="-120"/>
               </a:rPr>
-              <a:t>98.0%</a:t>
+              <a:t>60.4%</a:t>
             </a:r>
             <a:endParaRPr lang="en-US" sz="3400" dirty="0"/>
           </a:p>
@@ -7444,7 +7444,7 @@
                 <a:ea typeface="IBM Plex Mono" pitchFamily="34" charset="-122"/>
                 <a:cs typeface="IBM Plex Mono" pitchFamily="34" charset="-120"/>
               </a:rPr>
-              <a:t>BASELINE</a:t>
+              <a:t>REORDER BASELINE</a:t>
             </a:r>
             <a:endParaRPr lang="en-US" sz="850" dirty="0"/>
           </a:p>
@@ -7522,7 +7522,7 @@
                 <a:ea typeface="Barlow Condensed" pitchFamily="34" charset="-122"/>
                 <a:cs typeface="Barlow Condensed" pitchFamily="34" charset="-120"/>
               </a:rPr>
-              <a:t>99%+</a:t>
+              <a:t>80.2%</a:t>
             </a:r>
             <a:endParaRPr lang="en-US" sz="3400" dirty="0"/>
           </a:p>
@@ -7625,7 +7625,7 @@
                 <a:ea typeface="Barlow" pitchFamily="34" charset="-122"/>
                 <a:cs typeface="Barlow" pitchFamily="34" charset="-120"/>
               </a:rPr>
-              <a:t>Baseline already near-saturated. Interventions lock in subscription conversion and protect against drift at scale — subscription target: 25–30% of reorderers.</a:t>
+              <a:t>Loyalty price trigger converts 50% of lapsers (+19.8pp). Expert consultation captures the uncertain segment (+10.6pp). Combined lift closes the majority of the 39.6% lapse gap.</a:t>
             </a:r>
             <a:endParaRPr lang="en-US" sz="950" dirty="0"/>
           </a:p>
@@ -12372,7 +12372,7 @@
                 <a:ea typeface="Barlow" pitchFamily="34" charset="-122"/>
                 <a:cs typeface="Barlow" pitchFamily="34" charset="-120"/>
               </a:rPr>
-              <a:t>Journey A (Probiotic): 98% trial, near-100% reorder. Trigger-based nurture closes the remaining lapse segment. The product is saturated — the lever is timing.</a:t>
+              <a:t>Journey A (Nutrimix Age 2–6): 84.5% first purchase, 60.4% reorder. 39.6% lapse with no trigger at Day 55. Social proof and outcome data: 0% effect. Loyalty price prompt alone lifts reorder to 80.2%.</a:t>
             </a:r>
             <a:endParaRPr lang="en-US" sz="1100" dirty="0"/>
           </a:p>
@@ -12450,7 +12450,7 @@
                 <a:ea typeface="Barlow" pitchFamily="34" charset="-122"/>
                 <a:cs typeface="Barlow" pitchFamily="34" charset="-120"/>
               </a:rPr>
-              <a:t>Journey B (Magnesium Gummies): 32.5% trial, 23.1% reorder. A new category with one blocker — the pediatrician's veto. Fix that, and trial lifts to 90%; sleep tracking then takes reorder to 93.3%.</a:t>
+              <a:t>Journey B (Magnesium Gummies): 32.5% trial, 23.1% reorder. Pediatrician veto is the single acquisition blocker. Fix that: trial lifts to 90%. Sleep tracking then takes reorder from 23.1% → 93.3%.</a:t>
             </a:r>
             <a:endParaRPr lang="en-US" sz="1100" dirty="0"/>
           </a:p>
@@ -12528,7 +12528,7 @@
                 <a:ea typeface="Barlow" pitchFamily="34" charset="-122"/>
                 <a:cs typeface="Barlow" pitchFamily="34" charset="-120"/>
               </a:rPr>
-              <a:t>Journey C (Nutrimix): 37.2% trial, 27.3% reorder → 93.8% with interventions. Not a price problem. A format and timing problem. Family pack + child preference signal resolved it entirely.</a:t>
+              <a:t>Journey C (Nutrimix Age 7–14): 37.2% trial, 27.3% reorder → 93.8% with interventions. Not a price problem. A format and timing problem. Family pack + child preference resolved it entirely.</a:t>
             </a:r>
             <a:endParaRPr lang="en-US" sz="1100" dirty="0"/>
           </a:p>

</xml_diff>